<commit_message>
add new ideas for logo
</commit_message>
<xml_diff>
--- a/dmxlights_logo.pptx
+++ b/dmxlights_logo.pptx
@@ -6,6 +6,7 @@
   </p:sldMasterIdLst>
   <p:sldIdLst>
     <p:sldId id="256" r:id="rId2"/>
+    <p:sldId id="257" r:id="rId3"/>
   </p:sldIdLst>
   <p:sldSz cx="12192000" cy="6858000"/>
   <p:notesSz cx="6858000" cy="9144000"/>
@@ -259,7 +260,7 @@
           <a:p>
             <a:fld id="{1F6AB44A-9B02-E54E-8892-EF6C157D9637}" type="datetimeFigureOut">
               <a:rPr lang="en-US" smtClean="0"/>
-              <a:t>3/20/25</a:t>
+              <a:t>5/22/25</a:t>
             </a:fld>
             <a:endParaRPr lang="en-US"/>
           </a:p>
@@ -457,7 +458,7 @@
           <a:p>
             <a:fld id="{1F6AB44A-9B02-E54E-8892-EF6C157D9637}" type="datetimeFigureOut">
               <a:rPr lang="en-US" smtClean="0"/>
-              <a:t>3/20/25</a:t>
+              <a:t>5/22/25</a:t>
             </a:fld>
             <a:endParaRPr lang="en-US"/>
           </a:p>
@@ -665,7 +666,7 @@
           <a:p>
             <a:fld id="{1F6AB44A-9B02-E54E-8892-EF6C157D9637}" type="datetimeFigureOut">
               <a:rPr lang="en-US" smtClean="0"/>
-              <a:t>3/20/25</a:t>
+              <a:t>5/22/25</a:t>
             </a:fld>
             <a:endParaRPr lang="en-US"/>
           </a:p>
@@ -863,7 +864,7 @@
           <a:p>
             <a:fld id="{1F6AB44A-9B02-E54E-8892-EF6C157D9637}" type="datetimeFigureOut">
               <a:rPr lang="en-US" smtClean="0"/>
-              <a:t>3/20/25</a:t>
+              <a:t>5/22/25</a:t>
             </a:fld>
             <a:endParaRPr lang="en-US"/>
           </a:p>
@@ -1138,7 +1139,7 @@
           <a:p>
             <a:fld id="{1F6AB44A-9B02-E54E-8892-EF6C157D9637}" type="datetimeFigureOut">
               <a:rPr lang="en-US" smtClean="0"/>
-              <a:t>3/20/25</a:t>
+              <a:t>5/22/25</a:t>
             </a:fld>
             <a:endParaRPr lang="en-US"/>
           </a:p>
@@ -1403,7 +1404,7 @@
           <a:p>
             <a:fld id="{1F6AB44A-9B02-E54E-8892-EF6C157D9637}" type="datetimeFigureOut">
               <a:rPr lang="en-US" smtClean="0"/>
-              <a:t>3/20/25</a:t>
+              <a:t>5/22/25</a:t>
             </a:fld>
             <a:endParaRPr lang="en-US"/>
           </a:p>
@@ -1815,7 +1816,7 @@
           <a:p>
             <a:fld id="{1F6AB44A-9B02-E54E-8892-EF6C157D9637}" type="datetimeFigureOut">
               <a:rPr lang="en-US" smtClean="0"/>
-              <a:t>3/20/25</a:t>
+              <a:t>5/22/25</a:t>
             </a:fld>
             <a:endParaRPr lang="en-US"/>
           </a:p>
@@ -1956,7 +1957,7 @@
           <a:p>
             <a:fld id="{1F6AB44A-9B02-E54E-8892-EF6C157D9637}" type="datetimeFigureOut">
               <a:rPr lang="en-US" smtClean="0"/>
-              <a:t>3/20/25</a:t>
+              <a:t>5/22/25</a:t>
             </a:fld>
             <a:endParaRPr lang="en-US"/>
           </a:p>
@@ -2069,7 +2070,7 @@
           <a:p>
             <a:fld id="{1F6AB44A-9B02-E54E-8892-EF6C157D9637}" type="datetimeFigureOut">
               <a:rPr lang="en-US" smtClean="0"/>
-              <a:t>3/20/25</a:t>
+              <a:t>5/22/25</a:t>
             </a:fld>
             <a:endParaRPr lang="en-US"/>
           </a:p>
@@ -2380,7 +2381,7 @@
           <a:p>
             <a:fld id="{1F6AB44A-9B02-E54E-8892-EF6C157D9637}" type="datetimeFigureOut">
               <a:rPr lang="en-US" smtClean="0"/>
-              <a:t>3/20/25</a:t>
+              <a:t>5/22/25</a:t>
             </a:fld>
             <a:endParaRPr lang="en-US"/>
           </a:p>
@@ -2668,7 +2669,7 @@
           <a:p>
             <a:fld id="{1F6AB44A-9B02-E54E-8892-EF6C157D9637}" type="datetimeFigureOut">
               <a:rPr lang="en-US" smtClean="0"/>
-              <a:t>3/20/25</a:t>
+              <a:t>5/22/25</a:t>
             </a:fld>
             <a:endParaRPr lang="en-US"/>
           </a:p>
@@ -2909,7 +2910,7 @@
           <a:p>
             <a:fld id="{1F6AB44A-9B02-E54E-8892-EF6C157D9637}" type="datetimeFigureOut">
               <a:rPr lang="en-US" smtClean="0"/>
-              <a:t>3/20/25</a:t>
+              <a:t>5/22/25</a:t>
             </a:fld>
             <a:endParaRPr lang="en-US"/>
           </a:p>
@@ -3542,6 +3543,581 @@
 </p:sld>
 </file>
 
+<file path=ppt/slides/slide2.xml><?xml version="1.0" encoding="utf-8"?>
+<p:sld xmlns:a="http://schemas.openxmlformats.org/drawingml/2006/main" xmlns:r="http://schemas.openxmlformats.org/officeDocument/2006/relationships" xmlns:p="http://schemas.openxmlformats.org/presentationml/2006/main">
+  <p:cSld>
+    <p:spTree>
+      <p:nvGrpSpPr>
+        <p:cNvPr id="1" name=""/>
+        <p:cNvGrpSpPr/>
+        <p:nvPr/>
+      </p:nvGrpSpPr>
+      <p:grpSpPr>
+        <a:xfrm>
+          <a:off x="0" y="0"/>
+          <a:ext cx="0" cy="0"/>
+          <a:chOff x="0" y="0"/>
+          <a:chExt cx="0" cy="0"/>
+        </a:xfrm>
+      </p:grpSpPr>
+      <p:sp>
+        <p:nvSpPr>
+          <p:cNvPr id="4" name="TextBox 3">
+            <a:extLst>
+              <a:ext uri="{FF2B5EF4-FFF2-40B4-BE49-F238E27FC236}">
+                <a16:creationId xmlns:a16="http://schemas.microsoft.com/office/drawing/2014/main" id="{956591B7-E30F-BE4B-B4F8-D156B27BED4D}"/>
+              </a:ext>
+            </a:extLst>
+          </p:cNvPr>
+          <p:cNvSpPr txBox="1"/>
+          <p:nvPr/>
+        </p:nvSpPr>
+        <p:spPr>
+          <a:xfrm>
+            <a:off x="2388870" y="628649"/>
+            <a:ext cx="3454584" cy="3300413"/>
+          </a:xfrm>
+          <a:prstGeom prst="rect">
+            <a:avLst/>
+          </a:prstGeom>
+          <a:solidFill>
+            <a:srgbClr val="00B0F0"/>
+          </a:solidFill>
+          <a:ln w="57150">
+            <a:solidFill>
+              <a:schemeClr val="bg1">
+                <a:lumMod val="75000"/>
+              </a:schemeClr>
+            </a:solidFill>
+          </a:ln>
+        </p:spPr>
+        <p:txBody>
+          <a:bodyPr wrap="square" rtlCol="0">
+            <a:spAutoFit/>
+          </a:bodyPr>
+          <a:lstStyle/>
+          <a:p>
+            <a:endParaRPr lang="en-US" dirty="0"/>
+          </a:p>
+        </p:txBody>
+      </p:sp>
+      <p:cxnSp>
+        <p:nvCxnSpPr>
+          <p:cNvPr id="6" name="Straight Connector 5">
+            <a:extLst>
+              <a:ext uri="{FF2B5EF4-FFF2-40B4-BE49-F238E27FC236}">
+                <a16:creationId xmlns:a16="http://schemas.microsoft.com/office/drawing/2014/main" id="{D844DC4D-911A-2048-B1C2-ACB237A7FC7A}"/>
+              </a:ext>
+            </a:extLst>
+          </p:cNvPr>
+          <p:cNvCxnSpPr>
+            <a:cxnSpLocks/>
+          </p:cNvCxnSpPr>
+          <p:nvPr/>
+        </p:nvCxnSpPr>
+        <p:spPr>
+          <a:xfrm>
+            <a:off x="2586038" y="2214565"/>
+            <a:ext cx="3086728" cy="0"/>
+          </a:xfrm>
+          <a:prstGeom prst="line">
+            <a:avLst/>
+          </a:prstGeom>
+          <a:ln w="76200">
+            <a:solidFill>
+              <a:schemeClr val="bg1">
+                <a:lumMod val="85000"/>
+              </a:schemeClr>
+            </a:solidFill>
+          </a:ln>
+        </p:spPr>
+        <p:style>
+          <a:lnRef idx="1">
+            <a:schemeClr val="accent1"/>
+          </a:lnRef>
+          <a:fillRef idx="0">
+            <a:schemeClr val="accent1"/>
+          </a:fillRef>
+          <a:effectRef idx="0">
+            <a:schemeClr val="accent1"/>
+          </a:effectRef>
+          <a:fontRef idx="minor">
+            <a:schemeClr val="tx1"/>
+          </a:fontRef>
+        </p:style>
+      </p:cxnSp>
+      <p:sp>
+        <p:nvSpPr>
+          <p:cNvPr id="8" name="TextBox 7">
+            <a:extLst>
+              <a:ext uri="{FF2B5EF4-FFF2-40B4-BE49-F238E27FC236}">
+                <a16:creationId xmlns:a16="http://schemas.microsoft.com/office/drawing/2014/main" id="{B43710CE-7A9E-9546-B2F2-FB55AA3A77A6}"/>
+              </a:ext>
+            </a:extLst>
+          </p:cNvPr>
+          <p:cNvSpPr txBox="1"/>
+          <p:nvPr/>
+        </p:nvSpPr>
+        <p:spPr>
+          <a:xfrm>
+            <a:off x="2477532" y="328298"/>
+            <a:ext cx="3195234" cy="2215991"/>
+          </a:xfrm>
+          <a:prstGeom prst="rect">
+            <a:avLst/>
+          </a:prstGeom>
+          <a:noFill/>
+        </p:spPr>
+        <p:txBody>
+          <a:bodyPr wrap="none" rtlCol="0">
+            <a:spAutoFit/>
+          </a:bodyPr>
+          <a:lstStyle/>
+          <a:p>
+            <a:r>
+              <a:rPr lang="en-US" sz="13800" b="1" dirty="0">
+                <a:solidFill>
+                  <a:schemeClr val="bg1">
+                    <a:lumMod val="50000"/>
+                  </a:schemeClr>
+                </a:solidFill>
+              </a:rPr>
+              <a:t>PAD</a:t>
+            </a:r>
+          </a:p>
+        </p:txBody>
+      </p:sp>
+      <p:sp>
+        <p:nvSpPr>
+          <p:cNvPr id="9" name="TextBox 8">
+            <a:extLst>
+              <a:ext uri="{FF2B5EF4-FFF2-40B4-BE49-F238E27FC236}">
+                <a16:creationId xmlns:a16="http://schemas.microsoft.com/office/drawing/2014/main" id="{39AD3521-06F8-5449-AABE-CB55D2F865BD}"/>
+              </a:ext>
+            </a:extLst>
+          </p:cNvPr>
+          <p:cNvSpPr txBox="1"/>
+          <p:nvPr/>
+        </p:nvSpPr>
+        <p:spPr>
+          <a:xfrm>
+            <a:off x="2436084" y="2045767"/>
+            <a:ext cx="3386633" cy="1862048"/>
+          </a:xfrm>
+          <a:prstGeom prst="rect">
+            <a:avLst/>
+          </a:prstGeom>
+          <a:noFill/>
+        </p:spPr>
+        <p:txBody>
+          <a:bodyPr wrap="none" rtlCol="0">
+            <a:spAutoFit/>
+          </a:bodyPr>
+          <a:lstStyle/>
+          <a:p>
+            <a:r>
+              <a:rPr lang="en-US" sz="11500" dirty="0">
+                <a:solidFill>
+                  <a:schemeClr val="bg1">
+                    <a:lumMod val="75000"/>
+                  </a:schemeClr>
+                </a:solidFill>
+              </a:rPr>
+              <a:t>lights</a:t>
+            </a:r>
+          </a:p>
+        </p:txBody>
+      </p:sp>
+      <p:sp>
+        <p:nvSpPr>
+          <p:cNvPr id="10" name="TextBox 9">
+            <a:extLst>
+              <a:ext uri="{FF2B5EF4-FFF2-40B4-BE49-F238E27FC236}">
+                <a16:creationId xmlns:a16="http://schemas.microsoft.com/office/drawing/2014/main" id="{E7304F95-4779-1C47-8B8A-35F7C614B3B1}"/>
+              </a:ext>
+            </a:extLst>
+          </p:cNvPr>
+          <p:cNvSpPr txBox="1"/>
+          <p:nvPr/>
+        </p:nvSpPr>
+        <p:spPr>
+          <a:xfrm>
+            <a:off x="4545587" y="3538483"/>
+            <a:ext cx="1227195" cy="369332"/>
+          </a:xfrm>
+          <a:prstGeom prst="rect">
+            <a:avLst/>
+          </a:prstGeom>
+          <a:noFill/>
+        </p:spPr>
+        <p:txBody>
+          <a:bodyPr wrap="none" rtlCol="0">
+            <a:spAutoFit/>
+          </a:bodyPr>
+          <a:lstStyle/>
+          <a:p>
+            <a:r>
+              <a:rPr lang="en-US" dirty="0"/>
+              <a:t>Version 3.0</a:t>
+            </a:r>
+          </a:p>
+        </p:txBody>
+      </p:sp>
+      <p:sp>
+        <p:nvSpPr>
+          <p:cNvPr id="2" name="TextBox 1">
+            <a:extLst>
+              <a:ext uri="{FF2B5EF4-FFF2-40B4-BE49-F238E27FC236}">
+                <a16:creationId xmlns:a16="http://schemas.microsoft.com/office/drawing/2014/main" id="{E477C829-8C20-734D-A623-B6776E8571B8}"/>
+              </a:ext>
+            </a:extLst>
+          </p:cNvPr>
+          <p:cNvSpPr txBox="1"/>
+          <p:nvPr/>
+        </p:nvSpPr>
+        <p:spPr>
+          <a:xfrm>
+            <a:off x="4645438" y="1253954"/>
+            <a:ext cx="2329184" cy="1862048"/>
+          </a:xfrm>
+          <a:prstGeom prst="rect">
+            <a:avLst/>
+          </a:prstGeom>
+          <a:noFill/>
+        </p:spPr>
+        <p:txBody>
+          <a:bodyPr wrap="square" rtlCol="0">
+            <a:spAutoFit/>
+          </a:bodyPr>
+          <a:lstStyle/>
+          <a:p>
+            <a:r>
+              <a:rPr lang="en-US" sz="11500" b="1" i="1" dirty="0">
+                <a:solidFill>
+                  <a:srgbClr val="FFFF00"/>
+                </a:solidFill>
+                <a:latin typeface="Apple Chancery" panose="03020702040506060504" pitchFamily="66" charset="-79"/>
+                <a:cs typeface="Apple Chancery" panose="03020702040506060504" pitchFamily="66" charset="-79"/>
+              </a:rPr>
+              <a:t>4</a:t>
+            </a:r>
+          </a:p>
+        </p:txBody>
+      </p:sp>
+      <p:cxnSp>
+        <p:nvCxnSpPr>
+          <p:cNvPr id="5" name="Straight Connector 4">
+            <a:extLst>
+              <a:ext uri="{FF2B5EF4-FFF2-40B4-BE49-F238E27FC236}">
+                <a16:creationId xmlns:a16="http://schemas.microsoft.com/office/drawing/2014/main" id="{F94C7D78-034B-7143-A2F1-A25BBDCFB073}"/>
+              </a:ext>
+            </a:extLst>
+          </p:cNvPr>
+          <p:cNvCxnSpPr>
+            <a:cxnSpLocks/>
+          </p:cNvCxnSpPr>
+          <p:nvPr/>
+        </p:nvCxnSpPr>
+        <p:spPr>
+          <a:xfrm>
+            <a:off x="5444403" y="989123"/>
+            <a:ext cx="102258" cy="771167"/>
+          </a:xfrm>
+          <a:prstGeom prst="line">
+            <a:avLst/>
+          </a:prstGeom>
+          <a:ln w="73025">
+            <a:solidFill>
+              <a:srgbClr val="FFFF00"/>
+            </a:solidFill>
+          </a:ln>
+        </p:spPr>
+        <p:style>
+          <a:lnRef idx="1">
+            <a:schemeClr val="accent1"/>
+          </a:lnRef>
+          <a:fillRef idx="0">
+            <a:schemeClr val="accent1"/>
+          </a:fillRef>
+          <a:effectRef idx="0">
+            <a:schemeClr val="accent1"/>
+          </a:effectRef>
+          <a:fontRef idx="minor">
+            <a:schemeClr val="tx1"/>
+          </a:fontRef>
+        </p:style>
+      </p:cxnSp>
+      <p:cxnSp>
+        <p:nvCxnSpPr>
+          <p:cNvPr id="17" name="Straight Connector 16">
+            <a:extLst>
+              <a:ext uri="{FF2B5EF4-FFF2-40B4-BE49-F238E27FC236}">
+                <a16:creationId xmlns:a16="http://schemas.microsoft.com/office/drawing/2014/main" id="{FE2F93E7-2E7B-B546-9CB5-BFC051D8D581}"/>
+              </a:ext>
+            </a:extLst>
+          </p:cNvPr>
+          <p:cNvCxnSpPr>
+            <a:cxnSpLocks/>
+          </p:cNvCxnSpPr>
+          <p:nvPr/>
+        </p:nvCxnSpPr>
+        <p:spPr>
+          <a:xfrm>
+            <a:off x="4595524" y="1507688"/>
+            <a:ext cx="102258" cy="771167"/>
+          </a:xfrm>
+          <a:prstGeom prst="line">
+            <a:avLst/>
+          </a:prstGeom>
+          <a:ln w="73025">
+            <a:solidFill>
+              <a:srgbClr val="FFFF00"/>
+            </a:solidFill>
+          </a:ln>
+        </p:spPr>
+        <p:style>
+          <a:lnRef idx="1">
+            <a:schemeClr val="accent1"/>
+          </a:lnRef>
+          <a:fillRef idx="0">
+            <a:schemeClr val="accent1"/>
+          </a:fillRef>
+          <a:effectRef idx="0">
+            <a:schemeClr val="accent1"/>
+          </a:effectRef>
+          <a:fontRef idx="minor">
+            <a:schemeClr val="tx1"/>
+          </a:fontRef>
+        </p:style>
+      </p:cxnSp>
+      <p:cxnSp>
+        <p:nvCxnSpPr>
+          <p:cNvPr id="18" name="Straight Connector 17">
+            <a:extLst>
+              <a:ext uri="{FF2B5EF4-FFF2-40B4-BE49-F238E27FC236}">
+                <a16:creationId xmlns:a16="http://schemas.microsoft.com/office/drawing/2014/main" id="{FE16B888-D053-0B45-8B37-ACF56060D384}"/>
+              </a:ext>
+            </a:extLst>
+          </p:cNvPr>
+          <p:cNvCxnSpPr>
+            <a:cxnSpLocks/>
+          </p:cNvCxnSpPr>
+          <p:nvPr/>
+        </p:nvCxnSpPr>
+        <p:spPr>
+          <a:xfrm>
+            <a:off x="4764294" y="1400495"/>
+            <a:ext cx="102258" cy="771167"/>
+          </a:xfrm>
+          <a:prstGeom prst="line">
+            <a:avLst/>
+          </a:prstGeom>
+          <a:ln w="73025">
+            <a:solidFill>
+              <a:srgbClr val="FFFF00"/>
+            </a:solidFill>
+          </a:ln>
+        </p:spPr>
+        <p:style>
+          <a:lnRef idx="1">
+            <a:schemeClr val="accent1"/>
+          </a:lnRef>
+          <a:fillRef idx="0">
+            <a:schemeClr val="accent1"/>
+          </a:fillRef>
+          <a:effectRef idx="0">
+            <a:schemeClr val="accent1"/>
+          </a:effectRef>
+          <a:fontRef idx="minor">
+            <a:schemeClr val="tx1"/>
+          </a:fontRef>
+        </p:style>
+      </p:cxnSp>
+      <p:cxnSp>
+        <p:nvCxnSpPr>
+          <p:cNvPr id="19" name="Straight Connector 18">
+            <a:extLst>
+              <a:ext uri="{FF2B5EF4-FFF2-40B4-BE49-F238E27FC236}">
+                <a16:creationId xmlns:a16="http://schemas.microsoft.com/office/drawing/2014/main" id="{7B1BCE8F-77BC-2245-9903-AAFBF94CF16A}"/>
+              </a:ext>
+            </a:extLst>
+          </p:cNvPr>
+          <p:cNvCxnSpPr>
+            <a:cxnSpLocks/>
+          </p:cNvCxnSpPr>
+          <p:nvPr/>
+        </p:nvCxnSpPr>
+        <p:spPr>
+          <a:xfrm>
+            <a:off x="4923591" y="1293222"/>
+            <a:ext cx="102258" cy="771167"/>
+          </a:xfrm>
+          <a:prstGeom prst="line">
+            <a:avLst/>
+          </a:prstGeom>
+          <a:ln w="73025">
+            <a:solidFill>
+              <a:srgbClr val="FFFF00"/>
+            </a:solidFill>
+          </a:ln>
+        </p:spPr>
+        <p:style>
+          <a:lnRef idx="1">
+            <a:schemeClr val="accent1"/>
+          </a:lnRef>
+          <a:fillRef idx="0">
+            <a:schemeClr val="accent1"/>
+          </a:fillRef>
+          <a:effectRef idx="0">
+            <a:schemeClr val="accent1"/>
+          </a:effectRef>
+          <a:fontRef idx="minor">
+            <a:schemeClr val="tx1"/>
+          </a:fontRef>
+        </p:style>
+      </p:cxnSp>
+      <p:cxnSp>
+        <p:nvCxnSpPr>
+          <p:cNvPr id="20" name="Straight Connector 19">
+            <a:extLst>
+              <a:ext uri="{FF2B5EF4-FFF2-40B4-BE49-F238E27FC236}">
+                <a16:creationId xmlns:a16="http://schemas.microsoft.com/office/drawing/2014/main" id="{F4831963-6FE1-8846-BF78-420F58326D41}"/>
+              </a:ext>
+            </a:extLst>
+          </p:cNvPr>
+          <p:cNvCxnSpPr>
+            <a:cxnSpLocks/>
+          </p:cNvCxnSpPr>
+          <p:nvPr/>
+        </p:nvCxnSpPr>
+        <p:spPr>
+          <a:xfrm>
+            <a:off x="5087666" y="1195805"/>
+            <a:ext cx="102258" cy="771167"/>
+          </a:xfrm>
+          <a:prstGeom prst="line">
+            <a:avLst/>
+          </a:prstGeom>
+          <a:ln w="73025">
+            <a:solidFill>
+              <a:srgbClr val="FFFF00"/>
+            </a:solidFill>
+          </a:ln>
+        </p:spPr>
+        <p:style>
+          <a:lnRef idx="1">
+            <a:schemeClr val="accent1"/>
+          </a:lnRef>
+          <a:fillRef idx="0">
+            <a:schemeClr val="accent1"/>
+          </a:fillRef>
+          <a:effectRef idx="0">
+            <a:schemeClr val="accent1"/>
+          </a:effectRef>
+          <a:fontRef idx="minor">
+            <a:schemeClr val="tx1"/>
+          </a:fontRef>
+        </p:style>
+      </p:cxnSp>
+      <p:cxnSp>
+        <p:nvCxnSpPr>
+          <p:cNvPr id="21" name="Straight Connector 20">
+            <a:extLst>
+              <a:ext uri="{FF2B5EF4-FFF2-40B4-BE49-F238E27FC236}">
+                <a16:creationId xmlns:a16="http://schemas.microsoft.com/office/drawing/2014/main" id="{29098786-BDC3-BC4B-A676-A2DE04ED5547}"/>
+              </a:ext>
+            </a:extLst>
+          </p:cNvPr>
+          <p:cNvCxnSpPr>
+            <a:cxnSpLocks/>
+          </p:cNvCxnSpPr>
+          <p:nvPr/>
+        </p:nvCxnSpPr>
+        <p:spPr>
+          <a:xfrm>
+            <a:off x="5256436" y="1105060"/>
+            <a:ext cx="102258" cy="771167"/>
+          </a:xfrm>
+          <a:prstGeom prst="line">
+            <a:avLst/>
+          </a:prstGeom>
+          <a:ln w="73025">
+            <a:solidFill>
+              <a:srgbClr val="FFFF00"/>
+            </a:solidFill>
+          </a:ln>
+        </p:spPr>
+        <p:style>
+          <a:lnRef idx="1">
+            <a:schemeClr val="accent1"/>
+          </a:lnRef>
+          <a:fillRef idx="0">
+            <a:schemeClr val="accent1"/>
+          </a:fillRef>
+          <a:effectRef idx="0">
+            <a:schemeClr val="accent1"/>
+          </a:effectRef>
+          <a:fontRef idx="minor">
+            <a:schemeClr val="tx1"/>
+          </a:fontRef>
+        </p:style>
+      </p:cxnSp>
+      <p:cxnSp>
+        <p:nvCxnSpPr>
+          <p:cNvPr id="22" name="Straight Connector 21">
+            <a:extLst>
+              <a:ext uri="{FF2B5EF4-FFF2-40B4-BE49-F238E27FC236}">
+                <a16:creationId xmlns:a16="http://schemas.microsoft.com/office/drawing/2014/main" id="{DB1EE661-C545-144F-91C6-9166E909BB9A}"/>
+              </a:ext>
+            </a:extLst>
+          </p:cNvPr>
+          <p:cNvCxnSpPr>
+            <a:cxnSpLocks/>
+          </p:cNvCxnSpPr>
+          <p:nvPr/>
+        </p:nvCxnSpPr>
+        <p:spPr>
+          <a:xfrm>
+            <a:off x="5594354" y="859334"/>
+            <a:ext cx="102258" cy="771167"/>
+          </a:xfrm>
+          <a:prstGeom prst="line">
+            <a:avLst/>
+          </a:prstGeom>
+          <a:ln w="73025">
+            <a:solidFill>
+              <a:srgbClr val="FFFF00"/>
+            </a:solidFill>
+          </a:ln>
+        </p:spPr>
+        <p:style>
+          <a:lnRef idx="1">
+            <a:schemeClr val="accent1"/>
+          </a:lnRef>
+          <a:fillRef idx="0">
+            <a:schemeClr val="accent1"/>
+          </a:fillRef>
+          <a:effectRef idx="0">
+            <a:schemeClr val="accent1"/>
+          </a:effectRef>
+          <a:fontRef idx="minor">
+            <a:schemeClr val="tx1"/>
+          </a:fontRef>
+        </p:style>
+      </p:cxnSp>
+    </p:spTree>
+    <p:extLst>
+      <p:ext uri="{BB962C8B-B14F-4D97-AF65-F5344CB8AC3E}">
+        <p14:creationId xmlns:p14="http://schemas.microsoft.com/office/powerpoint/2010/main" val="3229475755"/>
+      </p:ext>
+    </p:extLst>
+  </p:cSld>
+  <p:clrMapOvr>
+    <a:masterClrMapping/>
+  </p:clrMapOvr>
+</p:sld>
+</file>
+
 <file path=ppt/theme/theme1.xml><?xml version="1.0" encoding="utf-8"?>
 <a:theme xmlns:a="http://schemas.openxmlformats.org/drawingml/2006/main" name="Office Theme">
   <a:themeElements>

</xml_diff>